<commit_message>
GroupDocs.Assembly for .NET 26.6 update
</commit_message>
<xml_diff>
--- a/Examples/Data/Artifacts/AssemblePresentationFromJson.pptx
+++ b/Examples/Data/Artifacts/AssemblePresentationFromJson.pptx
@@ -1,6 +1,6 @@
 
 <file path=ppt/presentation.xml><?xml version="1.0" encoding="utf-8"?>
-<!--Generated by Aspose.Slides for .NET 24.5-->
+<!--Generated by Aspose.Slides for .NET 26.6-->
 <p:presentation xmlns:r="http://schemas.openxmlformats.org/officeDocument/2006/relationships" xmlns:a="http://schemas.openxmlformats.org/drawingml/2006/main" xmlns:p="http://schemas.openxmlformats.org/presentationml/2006/main" saveSubsetFonts="1">
   <p:sldMasterIdLst>
     <p:sldMasterId id="2147483648" r:id="rId1"/>
@@ -108,11 +108,7 @@
       </a:defRPr>
     </a:lvl9pPr>
   </p:defaultTextStyle>
-  <p:extLst>
-    <p:ext uri="{EFAFB233-063F-42B5-8137-9DF3F51BA10A}">
-      <p15:sldGuideLst xmlns:p15="http://schemas.microsoft.com/office/powerpoint/2012/main"/>
-    </p:ext>
-  </p:extLst>
+  <p:extLst/>
 </p:presentation>
 </file>
 
@@ -3147,83 +3143,6 @@
           </a:graphicData>
         </a:graphic>
       </p:graphicFrame>
-      <p:sp>
-        <p:nvSpPr>
-          <p:cNvPr id="5" name="TextBox"/>
-          <p:cNvSpPr txBox="1">
-            <a:spLocks noGrp="1" noSelect="1" noRot="1" noMove="1"/>
-          </p:cNvSpPr>
-          <p:nvPr/>
-        </p:nvSpPr>
-        <p:spPr>
-          <a:xfrm>
-            <a:off x="2890520" y="2644140"/>
-            <a:ext cx="6411372" cy="1569660"/>
-          </a:xfrm>
-          <a:prstGeom prst="rect">
-            <a:avLst/>
-          </a:prstGeom>
-          <a:noFill/>
-        </p:spPr>
-        <p:txBody>
-          <a:bodyPr wrap="none" rtlCol="0" anchor="ctr" anchorCtr="1">
-            <a:spAutoFit/>
-          </a:bodyPr>
-          <a:lstStyle>
-            <a:lvl1pPr algn="l">
-              <a:lnSpc>
-                <a:spcPct val="150000"/>
-              </a:lnSpc>
-              <a:spcBef>
-                <a:spcPct val="0"/>
-              </a:spcBef>
-              <a:spcAft>
-                <a:spcPct val="0"/>
-              </a:spcAft>
-              <a:defRPr lang="en-US" sz="3200" b="1" noProof="1" dirty="0">
-                <a:solidFill>
-                  <a:prstClr val="red">
-                    <a:lumOff val="30000"/>
-                    <a:alpha val="40000"/>
-                  </a:prstClr>
-                </a:solidFill>
-                <a:effectLst>
-                  <a:outerShdw blurRad="50800" dist="38100" algn="tr" rotWithShape="0">
-                    <a:prstClr val="black">
-                      <a:alpha val="80000"/>
-                    </a:prstClr>
-                  </a:outerShdw>
-                </a:effectLst>
-                <a:latin typeface="Calibri" pitchFamily="34" charset="0"/>
-              </a:defRPr>
-            </a:lvl1pPr>
-          </a:lstStyle>
-          <a:p>
-            <a:pPr algn="ctr"/>
-            <a:r>
-              <a:t>Evaluation Only.</a:t>
-            </a:r>
-          </a:p>
-          <a:p>
-            <a:pPr algn="ctr"/>
-            <a:r>
-              <a:t>Created with GroupDocs.Assembly 25.12.</a:t>
-            </a:r>
-          </a:p>
-          <a:p>
-            <a:pPr algn="ctr"/>
-            <a:r>
-              <a:t>© Aspose Pty Ltd 2001-2025.</a:t>
-            </a:r>
-          </a:p>
-          <a:p>
-            <a:pPr algn="ctr"/>
-            <a:r>
-              <a:t>All Rights Reserved.</a:t>
-            </a:r>
-          </a:p>
-        </p:txBody>
-      </p:sp>
     </p:spTree>
     <p:extLst>
       <p:ext uri="{BB962C8B-B14F-4D97-AF65-F5344CB8AC3E}">
@@ -3241,11 +3160,11 @@
 
 <file path=ppt/tags/tag1.xml><?xml version="1.0" encoding="utf-8"?>
 <p:tagLst xmlns:p="http://schemas.openxmlformats.org/presentationml/2006/main">
-  <p:tag name="AS_NET" val="4.0.30319.42000"/>
-  <p:tag name="AS_OS" val="Microsoft Windows NT 6.2.9200.0"/>
-  <p:tag name="AS_RELEASE_DATE" val="2024.05.14"/>
-  <p:tag name="AS_TITLE" val="Aspose.Slides for .NET 4.0 Client Profile"/>
-  <p:tag name="AS_VERSION" val="24.5"/>
+  <p:tag name="AS_NET" val="10.0.9"/>
+  <p:tag name="AS_OS" val="Microsoft Windows NT 10.0.26200.0"/>
+  <p:tag name="AS_RELEASE_DATE" val="2026.06.14"/>
+  <p:tag name="AS_TITLE" val="Aspose.Slides for .NET6"/>
+  <p:tag name="AS_VERSION" val="26.6"/>
 </p:tagLst>
 </file>
 

</xml_diff>